<commit_message>
chore: update PowerPoint presentatie
Co-Authored-By: Claude Sonnet 4.6 <noreply@anthropic.com>
</commit_message>
<xml_diff>
--- a/Pollet_AI_Workspace_Assistant.pptx
+++ b/Pollet_AI_Workspace_Assistant.pptx
@@ -5,16 +5,16 @@
     <p:sldMasterId id="2147483648" r:id="rId1"/>
   </p:sldMasterIdLst>
   <p:sldIdLst>
-    <p:sldId id="256" r:id="rId7"/>
-    <p:sldId id="257" r:id="rId8"/>
-    <p:sldId id="258" r:id="rId9"/>
-    <p:sldId id="259" r:id="rId10"/>
-    <p:sldId id="260" r:id="rId11"/>
-    <p:sldId id="261" r:id="rId12"/>
-    <p:sldId id="262" r:id="rId13"/>
-    <p:sldId id="263" r:id="rId14"/>
+    <p:sldId id="256" r:id="rId2"/>
+    <p:sldId id="257" r:id="rId3"/>
+    <p:sldId id="258" r:id="rId4"/>
+    <p:sldId id="259" r:id="rId5"/>
+    <p:sldId id="260" r:id="rId6"/>
+    <p:sldId id="261" r:id="rId7"/>
+    <p:sldId id="262" r:id="rId8"/>
+    <p:sldId id="263" r:id="rId9"/>
   </p:sldIdLst>
-  <p:sldSz cx="12188952" cy="6858000" type="screen4x3"/>
+  <p:sldSz cx="12188825" cy="6858000"/>
   <p:notesSz cx="6858000" cy="9144000"/>
   <p:defaultTextStyle>
     <a:defPPr>
@@ -111,6 +111,22 @@
       </a:defRPr>
     </a:lvl9pPr>
   </p:defaultTextStyle>
+  <p:extLst>
+    <p:ext uri="{EFAFB233-063F-42B5-8137-9DF3F51BA10A}">
+      <p15:sldGuideLst xmlns:p15="http://schemas.microsoft.com/office/powerpoint/2012/main">
+        <p15:guide id="1" orient="horz" pos="2160">
+          <p15:clr>
+            <a:srgbClr val="A4A3A4"/>
+          </p15:clr>
+        </p15:guide>
+        <p15:guide id="2" pos="2880">
+          <p15:clr>
+            <a:srgbClr val="A4A3A4"/>
+          </p15:clr>
+        </p15:guide>
+      </p15:sldGuideLst>
+    </p:ext>
+  </p:extLst>
 </p:presentation>
 </file>
 
@@ -152,10 +168,9 @@
           <a:lstStyle/>
           <a:p>
             <a:r>
-              <a:rPr lang="en-US" smtClean="0"/>
+              <a:rPr lang="en-US"/>
               <a:t>Click to edit Master title style</a:t>
             </a:r>
-            <a:endParaRPr lang="en-US"/>
           </a:p>
         </p:txBody>
       </p:sp>
@@ -271,10 +286,9 @@
           </a:lstStyle>
           <a:p>
             <a:r>
-              <a:rPr lang="en-US" smtClean="0"/>
+              <a:rPr lang="en-US"/>
               <a:t>Click to edit Master subtitle style</a:t>
             </a:r>
-            <a:endParaRPr lang="en-US"/>
           </a:p>
         </p:txBody>
       </p:sp>
@@ -295,7 +309,7 @@
           <a:p>
             <a:fld id="{5BCAD085-E8A6-8845-BD4E-CB4CCA059FC4}" type="datetimeFigureOut">
               <a:rPr lang="en-US" smtClean="0"/>
-              <a:t>1/27/13</a:t>
+              <a:t>4/23/2026</a:t>
             </a:fld>
             <a:endParaRPr lang="en-US"/>
           </a:p>
@@ -389,10 +403,9 @@
           <a:lstStyle/>
           <a:p>
             <a:r>
-              <a:rPr lang="en-US" smtClean="0"/>
+              <a:rPr lang="en-US"/>
               <a:t>Click to edit Master title style</a:t>
             </a:r>
-            <a:endParaRPr lang="en-US"/>
           </a:p>
         </p:txBody>
       </p:sp>
@@ -413,38 +426,37 @@
           <a:p>
             <a:pPr lvl="0"/>
             <a:r>
-              <a:rPr lang="en-US" smtClean="0"/>
+              <a:rPr lang="en-US"/>
               <a:t>Click to edit Master text styles</a:t>
             </a:r>
           </a:p>
           <a:p>
             <a:pPr lvl="1"/>
             <a:r>
-              <a:rPr lang="en-US" smtClean="0"/>
+              <a:rPr lang="en-US"/>
               <a:t>Second level</a:t>
             </a:r>
           </a:p>
           <a:p>
             <a:pPr lvl="2"/>
             <a:r>
-              <a:rPr lang="en-US" smtClean="0"/>
+              <a:rPr lang="en-US"/>
               <a:t>Third level</a:t>
             </a:r>
           </a:p>
           <a:p>
             <a:pPr lvl="3"/>
             <a:r>
-              <a:rPr lang="en-US" smtClean="0"/>
+              <a:rPr lang="en-US"/>
               <a:t>Fourth level</a:t>
             </a:r>
           </a:p>
           <a:p>
             <a:pPr lvl="4"/>
             <a:r>
-              <a:rPr lang="en-US" smtClean="0"/>
+              <a:rPr lang="en-US"/>
               <a:t>Fifth level</a:t>
             </a:r>
-            <a:endParaRPr lang="en-US"/>
           </a:p>
         </p:txBody>
       </p:sp>
@@ -465,7 +477,7 @@
           <a:p>
             <a:fld id="{5BCAD085-E8A6-8845-BD4E-CB4CCA059FC4}" type="datetimeFigureOut">
               <a:rPr lang="en-US" smtClean="0"/>
-              <a:t>1/27/13</a:t>
+              <a:t>4/23/2026</a:t>
             </a:fld>
             <a:endParaRPr lang="en-US"/>
           </a:p>
@@ -564,10 +576,9 @@
           <a:lstStyle/>
           <a:p>
             <a:r>
-              <a:rPr lang="en-US" smtClean="0"/>
+              <a:rPr lang="en-US"/>
               <a:t>Click to edit Master title style</a:t>
             </a:r>
-            <a:endParaRPr lang="en-US"/>
           </a:p>
         </p:txBody>
       </p:sp>
@@ -593,38 +604,37 @@
           <a:p>
             <a:pPr lvl="0"/>
             <a:r>
-              <a:rPr lang="en-US" smtClean="0"/>
+              <a:rPr lang="en-US"/>
               <a:t>Click to edit Master text styles</a:t>
             </a:r>
           </a:p>
           <a:p>
             <a:pPr lvl="1"/>
             <a:r>
-              <a:rPr lang="en-US" smtClean="0"/>
+              <a:rPr lang="en-US"/>
               <a:t>Second level</a:t>
             </a:r>
           </a:p>
           <a:p>
             <a:pPr lvl="2"/>
             <a:r>
-              <a:rPr lang="en-US" smtClean="0"/>
+              <a:rPr lang="en-US"/>
               <a:t>Third level</a:t>
             </a:r>
           </a:p>
           <a:p>
             <a:pPr lvl="3"/>
             <a:r>
-              <a:rPr lang="en-US" smtClean="0"/>
+              <a:rPr lang="en-US"/>
               <a:t>Fourth level</a:t>
             </a:r>
           </a:p>
           <a:p>
             <a:pPr lvl="4"/>
             <a:r>
-              <a:rPr lang="en-US" smtClean="0"/>
+              <a:rPr lang="en-US"/>
               <a:t>Fifth level</a:t>
             </a:r>
-            <a:endParaRPr lang="en-US"/>
           </a:p>
         </p:txBody>
       </p:sp>
@@ -645,7 +655,7 @@
           <a:p>
             <a:fld id="{5BCAD085-E8A6-8845-BD4E-CB4CCA059FC4}" type="datetimeFigureOut">
               <a:rPr lang="en-US" smtClean="0"/>
-              <a:t>1/27/13</a:t>
+              <a:t>4/23/2026</a:t>
             </a:fld>
             <a:endParaRPr lang="en-US"/>
           </a:p>
@@ -739,10 +749,9 @@
           <a:lstStyle/>
           <a:p>
             <a:r>
-              <a:rPr lang="en-US" smtClean="0"/>
+              <a:rPr lang="en-US"/>
               <a:t>Click to edit Master title style</a:t>
             </a:r>
-            <a:endParaRPr lang="en-US"/>
           </a:p>
         </p:txBody>
       </p:sp>
@@ -763,38 +772,37 @@
           <a:p>
             <a:pPr lvl="0"/>
             <a:r>
-              <a:rPr lang="en-US" smtClean="0"/>
+              <a:rPr lang="en-US"/>
               <a:t>Click to edit Master text styles</a:t>
             </a:r>
           </a:p>
           <a:p>
             <a:pPr lvl="1"/>
             <a:r>
-              <a:rPr lang="en-US" smtClean="0"/>
+              <a:rPr lang="en-US"/>
               <a:t>Second level</a:t>
             </a:r>
           </a:p>
           <a:p>
             <a:pPr lvl="2"/>
             <a:r>
-              <a:rPr lang="en-US" smtClean="0"/>
+              <a:rPr lang="en-US"/>
               <a:t>Third level</a:t>
             </a:r>
           </a:p>
           <a:p>
             <a:pPr lvl="3"/>
             <a:r>
-              <a:rPr lang="en-US" smtClean="0"/>
+              <a:rPr lang="en-US"/>
               <a:t>Fourth level</a:t>
             </a:r>
           </a:p>
           <a:p>
             <a:pPr lvl="4"/>
             <a:r>
-              <a:rPr lang="en-US" smtClean="0"/>
+              <a:rPr lang="en-US"/>
               <a:t>Fifth level</a:t>
             </a:r>
-            <a:endParaRPr lang="en-US"/>
           </a:p>
         </p:txBody>
       </p:sp>
@@ -815,7 +823,7 @@
           <a:p>
             <a:fld id="{5BCAD085-E8A6-8845-BD4E-CB4CCA059FC4}" type="datetimeFigureOut">
               <a:rPr lang="en-US" smtClean="0"/>
-              <a:t>1/27/13</a:t>
+              <a:t>4/23/2026</a:t>
             </a:fld>
             <a:endParaRPr lang="en-US"/>
           </a:p>
@@ -918,10 +926,9 @@
           </a:lstStyle>
           <a:p>
             <a:r>
-              <a:rPr lang="en-US" smtClean="0"/>
+              <a:rPr lang="en-US"/>
               <a:t>Click to edit Master title style</a:t>
             </a:r>
-            <a:endParaRPr lang="en-US"/>
           </a:p>
         </p:txBody>
       </p:sp>
@@ -1038,7 +1045,7 @@
           <a:p>
             <a:pPr lvl="0"/>
             <a:r>
-              <a:rPr lang="en-US" smtClean="0"/>
+              <a:rPr lang="en-US"/>
               <a:t>Click to edit Master text styles</a:t>
             </a:r>
           </a:p>
@@ -1061,7 +1068,7 @@
           <a:p>
             <a:fld id="{5BCAD085-E8A6-8845-BD4E-CB4CCA059FC4}" type="datetimeFigureOut">
               <a:rPr lang="en-US" smtClean="0"/>
-              <a:t>1/27/13</a:t>
+              <a:t>4/23/2026</a:t>
             </a:fld>
             <a:endParaRPr lang="en-US"/>
           </a:p>
@@ -1155,10 +1162,9 @@
           <a:lstStyle/>
           <a:p>
             <a:r>
-              <a:rPr lang="en-US" smtClean="0"/>
+              <a:rPr lang="en-US"/>
               <a:t>Click to edit Master title style</a:t>
             </a:r>
-            <a:endParaRPr lang="en-US"/>
           </a:p>
         </p:txBody>
       </p:sp>
@@ -1212,38 +1218,37 @@
           <a:p>
             <a:pPr lvl="0"/>
             <a:r>
-              <a:rPr lang="en-US" smtClean="0"/>
+              <a:rPr lang="en-US"/>
               <a:t>Click to edit Master text styles</a:t>
             </a:r>
           </a:p>
           <a:p>
             <a:pPr lvl="1"/>
             <a:r>
-              <a:rPr lang="en-US" smtClean="0"/>
+              <a:rPr lang="en-US"/>
               <a:t>Second level</a:t>
             </a:r>
           </a:p>
           <a:p>
             <a:pPr lvl="2"/>
             <a:r>
-              <a:rPr lang="en-US" smtClean="0"/>
+              <a:rPr lang="en-US"/>
               <a:t>Third level</a:t>
             </a:r>
           </a:p>
           <a:p>
             <a:pPr lvl="3"/>
             <a:r>
-              <a:rPr lang="en-US" smtClean="0"/>
+              <a:rPr lang="en-US"/>
               <a:t>Fourth level</a:t>
             </a:r>
           </a:p>
           <a:p>
             <a:pPr lvl="4"/>
             <a:r>
-              <a:rPr lang="en-US" smtClean="0"/>
+              <a:rPr lang="en-US"/>
               <a:t>Fifth level</a:t>
             </a:r>
-            <a:endParaRPr lang="en-US"/>
           </a:p>
         </p:txBody>
       </p:sp>
@@ -1297,38 +1302,37 @@
           <a:p>
             <a:pPr lvl="0"/>
             <a:r>
-              <a:rPr lang="en-US" smtClean="0"/>
+              <a:rPr lang="en-US"/>
               <a:t>Click to edit Master text styles</a:t>
             </a:r>
           </a:p>
           <a:p>
             <a:pPr lvl="1"/>
             <a:r>
-              <a:rPr lang="en-US" smtClean="0"/>
+              <a:rPr lang="en-US"/>
               <a:t>Second level</a:t>
             </a:r>
           </a:p>
           <a:p>
             <a:pPr lvl="2"/>
             <a:r>
-              <a:rPr lang="en-US" smtClean="0"/>
+              <a:rPr lang="en-US"/>
               <a:t>Third level</a:t>
             </a:r>
           </a:p>
           <a:p>
             <a:pPr lvl="3"/>
             <a:r>
-              <a:rPr lang="en-US" smtClean="0"/>
+              <a:rPr lang="en-US"/>
               <a:t>Fourth level</a:t>
             </a:r>
           </a:p>
           <a:p>
             <a:pPr lvl="4"/>
             <a:r>
-              <a:rPr lang="en-US" smtClean="0"/>
+              <a:rPr lang="en-US"/>
               <a:t>Fifth level</a:t>
             </a:r>
-            <a:endParaRPr lang="en-US"/>
           </a:p>
         </p:txBody>
       </p:sp>
@@ -1349,7 +1353,7 @@
           <a:p>
             <a:fld id="{5BCAD085-E8A6-8845-BD4E-CB4CCA059FC4}" type="datetimeFigureOut">
               <a:rPr lang="en-US" smtClean="0"/>
-              <a:t>1/27/13</a:t>
+              <a:t>4/23/2026</a:t>
             </a:fld>
             <a:endParaRPr lang="en-US"/>
           </a:p>
@@ -1447,10 +1451,9 @@
           </a:lstStyle>
           <a:p>
             <a:r>
-              <a:rPr lang="en-US" smtClean="0"/>
+              <a:rPr lang="en-US"/>
               <a:t>Click to edit Master title style</a:t>
             </a:r>
-            <a:endParaRPr lang="en-US"/>
           </a:p>
         </p:txBody>
       </p:sp>
@@ -1513,7 +1516,7 @@
           <a:p>
             <a:pPr lvl="0"/>
             <a:r>
-              <a:rPr lang="en-US" smtClean="0"/>
+              <a:rPr lang="en-US"/>
               <a:t>Click to edit Master text styles</a:t>
             </a:r>
           </a:p>
@@ -1569,38 +1572,37 @@
           <a:p>
             <a:pPr lvl="0"/>
             <a:r>
-              <a:rPr lang="en-US" smtClean="0"/>
+              <a:rPr lang="en-US"/>
               <a:t>Click to edit Master text styles</a:t>
             </a:r>
           </a:p>
           <a:p>
             <a:pPr lvl="1"/>
             <a:r>
-              <a:rPr lang="en-US" smtClean="0"/>
+              <a:rPr lang="en-US"/>
               <a:t>Second level</a:t>
             </a:r>
           </a:p>
           <a:p>
             <a:pPr lvl="2"/>
             <a:r>
-              <a:rPr lang="en-US" smtClean="0"/>
+              <a:rPr lang="en-US"/>
               <a:t>Third level</a:t>
             </a:r>
           </a:p>
           <a:p>
             <a:pPr lvl="3"/>
             <a:r>
-              <a:rPr lang="en-US" smtClean="0"/>
+              <a:rPr lang="en-US"/>
               <a:t>Fourth level</a:t>
             </a:r>
           </a:p>
           <a:p>
             <a:pPr lvl="4"/>
             <a:r>
-              <a:rPr lang="en-US" smtClean="0"/>
+              <a:rPr lang="en-US"/>
               <a:t>Fifth level</a:t>
             </a:r>
-            <a:endParaRPr lang="en-US"/>
           </a:p>
         </p:txBody>
       </p:sp>
@@ -1663,7 +1665,7 @@
           <a:p>
             <a:pPr lvl="0"/>
             <a:r>
-              <a:rPr lang="en-US" smtClean="0"/>
+              <a:rPr lang="en-US"/>
               <a:t>Click to edit Master text styles</a:t>
             </a:r>
           </a:p>
@@ -1719,38 +1721,37 @@
           <a:p>
             <a:pPr lvl="0"/>
             <a:r>
-              <a:rPr lang="en-US" smtClean="0"/>
+              <a:rPr lang="en-US"/>
               <a:t>Click to edit Master text styles</a:t>
             </a:r>
           </a:p>
           <a:p>
             <a:pPr lvl="1"/>
             <a:r>
-              <a:rPr lang="en-US" smtClean="0"/>
+              <a:rPr lang="en-US"/>
               <a:t>Second level</a:t>
             </a:r>
           </a:p>
           <a:p>
             <a:pPr lvl="2"/>
             <a:r>
-              <a:rPr lang="en-US" smtClean="0"/>
+              <a:rPr lang="en-US"/>
               <a:t>Third level</a:t>
             </a:r>
           </a:p>
           <a:p>
             <a:pPr lvl="3"/>
             <a:r>
-              <a:rPr lang="en-US" smtClean="0"/>
+              <a:rPr lang="en-US"/>
               <a:t>Fourth level</a:t>
             </a:r>
           </a:p>
           <a:p>
             <a:pPr lvl="4"/>
             <a:r>
-              <a:rPr lang="en-US" smtClean="0"/>
+              <a:rPr lang="en-US"/>
               <a:t>Fifth level</a:t>
             </a:r>
-            <a:endParaRPr lang="en-US"/>
           </a:p>
         </p:txBody>
       </p:sp>
@@ -1771,7 +1772,7 @@
           <a:p>
             <a:fld id="{5BCAD085-E8A6-8845-BD4E-CB4CCA059FC4}" type="datetimeFigureOut">
               <a:rPr lang="en-US" smtClean="0"/>
-              <a:t>1/27/13</a:t>
+              <a:t>4/23/2026</a:t>
             </a:fld>
             <a:endParaRPr lang="en-US"/>
           </a:p>
@@ -1865,10 +1866,9 @@
           <a:lstStyle/>
           <a:p>
             <a:r>
-              <a:rPr lang="en-US" smtClean="0"/>
+              <a:rPr lang="en-US"/>
               <a:t>Click to edit Master title style</a:t>
             </a:r>
-            <a:endParaRPr lang="en-US"/>
           </a:p>
         </p:txBody>
       </p:sp>
@@ -1889,7 +1889,7 @@
           <a:p>
             <a:fld id="{5BCAD085-E8A6-8845-BD4E-CB4CCA059FC4}" type="datetimeFigureOut">
               <a:rPr lang="en-US" smtClean="0"/>
-              <a:t>1/27/13</a:t>
+              <a:t>4/23/2026</a:t>
             </a:fld>
             <a:endParaRPr lang="en-US"/>
           </a:p>
@@ -1984,7 +1984,7 @@
           <a:p>
             <a:fld id="{5BCAD085-E8A6-8845-BD4E-CB4CCA059FC4}" type="datetimeFigureOut">
               <a:rPr lang="en-US" smtClean="0"/>
-              <a:t>1/27/13</a:t>
+              <a:t>4/23/2026</a:t>
             </a:fld>
             <a:endParaRPr lang="en-US"/>
           </a:p>
@@ -2087,10 +2087,9 @@
           </a:lstStyle>
           <a:p>
             <a:r>
-              <a:rPr lang="en-US" smtClean="0"/>
+              <a:rPr lang="en-US"/>
               <a:t>Click to edit Master title style</a:t>
             </a:r>
-            <a:endParaRPr lang="en-US"/>
           </a:p>
         </p:txBody>
       </p:sp>
@@ -2144,38 +2143,37 @@
           <a:p>
             <a:pPr lvl="0"/>
             <a:r>
-              <a:rPr lang="en-US" smtClean="0"/>
+              <a:rPr lang="en-US"/>
               <a:t>Click to edit Master text styles</a:t>
             </a:r>
           </a:p>
           <a:p>
             <a:pPr lvl="1"/>
             <a:r>
-              <a:rPr lang="en-US" smtClean="0"/>
+              <a:rPr lang="en-US"/>
               <a:t>Second level</a:t>
             </a:r>
           </a:p>
           <a:p>
             <a:pPr lvl="2"/>
             <a:r>
-              <a:rPr lang="en-US" smtClean="0"/>
+              <a:rPr lang="en-US"/>
               <a:t>Third level</a:t>
             </a:r>
           </a:p>
           <a:p>
             <a:pPr lvl="3"/>
             <a:r>
-              <a:rPr lang="en-US" smtClean="0"/>
+              <a:rPr lang="en-US"/>
               <a:t>Fourth level</a:t>
             </a:r>
           </a:p>
           <a:p>
             <a:pPr lvl="4"/>
             <a:r>
-              <a:rPr lang="en-US" smtClean="0"/>
+              <a:rPr lang="en-US"/>
               <a:t>Fifth level</a:t>
             </a:r>
-            <a:endParaRPr lang="en-US"/>
           </a:p>
         </p:txBody>
       </p:sp>
@@ -2238,7 +2236,7 @@
           <a:p>
             <a:pPr lvl="0"/>
             <a:r>
-              <a:rPr lang="en-US" smtClean="0"/>
+              <a:rPr lang="en-US"/>
               <a:t>Click to edit Master text styles</a:t>
             </a:r>
           </a:p>
@@ -2261,7 +2259,7 @@
           <a:p>
             <a:fld id="{5BCAD085-E8A6-8845-BD4E-CB4CCA059FC4}" type="datetimeFigureOut">
               <a:rPr lang="en-US" smtClean="0"/>
-              <a:t>1/27/13</a:t>
+              <a:t>4/23/2026</a:t>
             </a:fld>
             <a:endParaRPr lang="en-US"/>
           </a:p>
@@ -2364,10 +2362,9 @@
           </a:lstStyle>
           <a:p>
             <a:r>
-              <a:rPr lang="en-US" smtClean="0"/>
+              <a:rPr lang="en-US"/>
               <a:t>Click to edit Master title style</a:t>
             </a:r>
-            <a:endParaRPr lang="en-US"/>
           </a:p>
         </p:txBody>
       </p:sp>
@@ -2491,7 +2488,7 @@
           <a:p>
             <a:pPr lvl="0"/>
             <a:r>
-              <a:rPr lang="en-US" smtClean="0"/>
+              <a:rPr lang="en-US"/>
               <a:t>Click to edit Master text styles</a:t>
             </a:r>
           </a:p>
@@ -2514,7 +2511,7 @@
           <a:p>
             <a:fld id="{5BCAD085-E8A6-8845-BD4E-CB4CCA059FC4}" type="datetimeFigureOut">
               <a:rPr lang="en-US" smtClean="0"/>
-              <a:t>1/27/13</a:t>
+              <a:t>4/23/2026</a:t>
             </a:fld>
             <a:endParaRPr lang="en-US"/>
           </a:p>
@@ -2623,10 +2620,9 @@
           <a:lstStyle/>
           <a:p>
             <a:r>
-              <a:rPr lang="en-US" smtClean="0"/>
+              <a:rPr lang="en-US"/>
               <a:t>Click to edit Master title style</a:t>
             </a:r>
-            <a:endParaRPr lang="en-US"/>
           </a:p>
         </p:txBody>
       </p:sp>
@@ -2657,38 +2653,37 @@
           <a:p>
             <a:pPr lvl="0"/>
             <a:r>
-              <a:rPr lang="en-US" smtClean="0"/>
+              <a:rPr lang="en-US"/>
               <a:t>Click to edit Master text styles</a:t>
             </a:r>
           </a:p>
           <a:p>
             <a:pPr lvl="1"/>
             <a:r>
-              <a:rPr lang="en-US" smtClean="0"/>
+              <a:rPr lang="en-US"/>
               <a:t>Second level</a:t>
             </a:r>
           </a:p>
           <a:p>
             <a:pPr lvl="2"/>
             <a:r>
-              <a:rPr lang="en-US" smtClean="0"/>
+              <a:rPr lang="en-US"/>
               <a:t>Third level</a:t>
             </a:r>
           </a:p>
           <a:p>
             <a:pPr lvl="3"/>
             <a:r>
-              <a:rPr lang="en-US" smtClean="0"/>
+              <a:rPr lang="en-US"/>
               <a:t>Fourth level</a:t>
             </a:r>
           </a:p>
           <a:p>
             <a:pPr lvl="4"/>
             <a:r>
-              <a:rPr lang="en-US" smtClean="0"/>
+              <a:rPr lang="en-US"/>
               <a:t>Fifth level</a:t>
             </a:r>
-            <a:endParaRPr lang="en-US"/>
           </a:p>
         </p:txBody>
       </p:sp>
@@ -2727,7 +2722,7 @@
           <a:p>
             <a:fld id="{5BCAD085-E8A6-8845-BD4E-CB4CCA059FC4}" type="datetimeFigureOut">
               <a:rPr lang="en-US" smtClean="0"/>
-              <a:t>1/27/13</a:t>
+              <a:t>4/23/2026</a:t>
             </a:fld>
             <a:endParaRPr lang="en-US"/>
           </a:p>
@@ -3086,7 +3081,7 @@
 </file>
 
 <file path=ppt/slides/slide1.xml><?xml version="1.0" encoding="utf-8"?>
-<p:sld xmlns:a="http://schemas.openxmlformats.org/drawingml/2006/main" xmlns:p="http://schemas.openxmlformats.org/presentationml/2006/main" xmlns:r="http://schemas.openxmlformats.org/officeDocument/2006/relationships">
+<p:sld xmlns:a="http://schemas.openxmlformats.org/drawingml/2006/main" xmlns:r="http://schemas.openxmlformats.org/officeDocument/2006/relationships" xmlns:p="http://schemas.openxmlformats.org/presentationml/2006/main">
   <p:cSld>
     <p:spTree>
       <p:nvGrpSpPr>
@@ -3094,7 +3089,14 @@
         <p:cNvGrpSpPr/>
         <p:nvPr/>
       </p:nvGrpSpPr>
-      <p:grpSpPr/>
+      <p:grpSpPr>
+        <a:xfrm>
+          <a:off x="0" y="0"/>
+          <a:ext cx="0" cy="0"/>
+          <a:chOff x="0" y="0"/>
+          <a:chExt cx="0" cy="0"/>
+        </a:xfrm>
+      </p:grpSpPr>
       <p:sp>
         <p:nvSpPr>
           <p:cNvPr id="2" name="Rectangle 1"/>
@@ -3135,6 +3137,7 @@
           <a:lstStyle/>
           <a:p>
             <a:pPr algn="ctr"/>
+            <a:endParaRPr/>
           </a:p>
         </p:txBody>
       </p:sp>
@@ -3178,6 +3181,7 @@
           <a:lstStyle/>
           <a:p>
             <a:pPr algn="ctr"/>
+            <a:endParaRPr/>
           </a:p>
         </p:txBody>
       </p:sp>
@@ -3221,6 +3225,7 @@
           <a:lstStyle/>
           <a:p>
             <a:pPr algn="ctr"/>
+            <a:endParaRPr/>
           </a:p>
         </p:txBody>
       </p:sp>
@@ -3570,6 +3575,7 @@
           <a:lstStyle/>
           <a:p>
             <a:pPr algn="ctr"/>
+            <a:endParaRPr/>
           </a:p>
         </p:txBody>
       </p:sp>
@@ -3616,7 +3622,7 @@
 </file>
 
 <file path=ppt/slides/slide2.xml><?xml version="1.0" encoding="utf-8"?>
-<p:sld xmlns:a="http://schemas.openxmlformats.org/drawingml/2006/main" xmlns:p="http://schemas.openxmlformats.org/presentationml/2006/main" xmlns:r="http://schemas.openxmlformats.org/officeDocument/2006/relationships">
+<p:sld xmlns:a="http://schemas.openxmlformats.org/drawingml/2006/main" xmlns:r="http://schemas.openxmlformats.org/officeDocument/2006/relationships" xmlns:p="http://schemas.openxmlformats.org/presentationml/2006/main">
   <p:cSld>
     <p:spTree>
       <p:nvGrpSpPr>
@@ -3624,7 +3630,14 @@
         <p:cNvGrpSpPr/>
         <p:nvPr/>
       </p:nvGrpSpPr>
-      <p:grpSpPr/>
+      <p:grpSpPr>
+        <a:xfrm>
+          <a:off x="0" y="0"/>
+          <a:ext cx="0" cy="0"/>
+          <a:chOff x="0" y="0"/>
+          <a:chExt cx="0" cy="0"/>
+        </a:xfrm>
+      </p:grpSpPr>
       <p:sp>
         <p:nvSpPr>
           <p:cNvPr id="2" name="Rectangle 1"/>
@@ -3665,6 +3678,7 @@
           <a:lstStyle/>
           <a:p>
             <a:pPr algn="ctr"/>
+            <a:endParaRPr/>
           </a:p>
         </p:txBody>
       </p:sp>
@@ -3708,6 +3722,7 @@
           <a:lstStyle/>
           <a:p>
             <a:pPr algn="ctr"/>
+            <a:endParaRPr/>
           </a:p>
         </p:txBody>
       </p:sp>
@@ -3819,6 +3834,7 @@
           <a:lstStyle/>
           <a:p>
             <a:pPr algn="ctr"/>
+            <a:endParaRPr/>
           </a:p>
         </p:txBody>
       </p:sp>
@@ -3862,6 +3878,7 @@
           <a:lstStyle/>
           <a:p>
             <a:pPr algn="ctr"/>
+            <a:endParaRPr/>
           </a:p>
         </p:txBody>
       </p:sp>
@@ -3905,6 +3922,7 @@
           <a:lstStyle/>
           <a:p>
             <a:pPr algn="ctr"/>
+            <a:endParaRPr/>
           </a:p>
         </p:txBody>
       </p:sp>
@@ -4016,6 +4034,7 @@
           <a:lstStyle/>
           <a:p>
             <a:pPr algn="ctr"/>
+            <a:endParaRPr/>
           </a:p>
         </p:txBody>
       </p:sp>
@@ -4059,6 +4078,7 @@
           <a:lstStyle/>
           <a:p>
             <a:pPr algn="ctr"/>
+            <a:endParaRPr/>
           </a:p>
         </p:txBody>
       </p:sp>
@@ -4170,6 +4190,7 @@
           <a:lstStyle/>
           <a:p>
             <a:pPr algn="ctr"/>
+            <a:endParaRPr/>
           </a:p>
         </p:txBody>
       </p:sp>
@@ -4213,6 +4234,7 @@
           <a:lstStyle/>
           <a:p>
             <a:pPr algn="ctr"/>
+            <a:endParaRPr/>
           </a:p>
         </p:txBody>
       </p:sp>
@@ -4240,13 +4262,42 @@
           <a:p>
             <a:pPr algn="l"/>
             <a:r>
-              <a:rPr sz="1600" b="1" i="0">
+              <a:rPr sz="1600" b="1" i="0" dirty="0">
                 <a:solidFill>
                   <a:srgbClr val="0F1F35"/>
                 </a:solidFill>
               </a:rPr>
-              <a:t>🗂️  Versnipperde klantinfo</a:t>
-            </a:r>
+              <a:t>🗂️  </a:t>
+            </a:r>
+            <a:r>
+              <a:rPr sz="1600" b="1" i="0" dirty="0" err="1">
+                <a:solidFill>
+                  <a:srgbClr val="0F1F35"/>
+                </a:solidFill>
+              </a:rPr>
+              <a:t>Versnipperde</a:t>
+            </a:r>
+            <a:r>
+              <a:rPr sz="1600" b="1" i="0" dirty="0">
+                <a:solidFill>
+                  <a:srgbClr val="0F1F35"/>
+                </a:solidFill>
+              </a:rPr>
+              <a:t> </a:t>
+            </a:r>
+            <a:r>
+              <a:rPr sz="1600" b="1" i="0" dirty="0" err="1">
+                <a:solidFill>
+                  <a:srgbClr val="0F1F35"/>
+                </a:solidFill>
+              </a:rPr>
+              <a:t>klantinfo</a:t>
+            </a:r>
+            <a:endParaRPr sz="1600" b="1" i="0" dirty="0">
+              <a:solidFill>
+                <a:srgbClr val="0F1F35"/>
+              </a:solidFill>
+            </a:endParaRPr>
           </a:p>
         </p:txBody>
       </p:sp>
@@ -4324,6 +4375,7 @@
           <a:lstStyle/>
           <a:p>
             <a:pPr algn="ctr"/>
+            <a:endParaRPr/>
           </a:p>
         </p:txBody>
       </p:sp>
@@ -4367,6 +4419,7 @@
           <a:lstStyle/>
           <a:p>
             <a:pPr algn="ctr"/>
+            <a:endParaRPr/>
           </a:p>
         </p:txBody>
       </p:sp>
@@ -4379,7 +4432,7 @@
         <p:spPr>
           <a:xfrm>
             <a:off x="594360" y="5257800"/>
-            <a:ext cx="3657600" cy="411480"/>
+            <a:ext cx="3657600" cy="338554"/>
           </a:xfrm>
           <a:prstGeom prst="rect">
             <a:avLst/>
@@ -4394,13 +4447,26 @@
           <a:p>
             <a:pPr algn="l"/>
             <a:r>
-              <a:rPr sz="1600" b="1" i="0">
+              <a:rPr sz="1600" b="1" i="0" dirty="0">
                 <a:solidFill>
                   <a:srgbClr val="0F1F35"/>
                 </a:solidFill>
               </a:rPr>
-              <a:t>🧠  Kennisverliess</a:t>
-            </a:r>
+              <a:t>🧠  </a:t>
+            </a:r>
+            <a:r>
+              <a:rPr sz="1600" b="1" i="0" dirty="0" err="1">
+                <a:solidFill>
+                  <a:srgbClr val="0F1F35"/>
+                </a:solidFill>
+              </a:rPr>
+              <a:t>Kennisverlies</a:t>
+            </a:r>
+            <a:endParaRPr sz="1600" b="1" i="0" dirty="0">
+              <a:solidFill>
+                <a:srgbClr val="0F1F35"/>
+              </a:solidFill>
+            </a:endParaRPr>
           </a:p>
         </p:txBody>
       </p:sp>
@@ -4447,7 +4513,7 @@
 </file>
 
 <file path=ppt/slides/slide3.xml><?xml version="1.0" encoding="utf-8"?>
-<p:sld xmlns:a="http://schemas.openxmlformats.org/drawingml/2006/main" xmlns:p="http://schemas.openxmlformats.org/presentationml/2006/main" xmlns:r="http://schemas.openxmlformats.org/officeDocument/2006/relationships">
+<p:sld xmlns:a="http://schemas.openxmlformats.org/drawingml/2006/main" xmlns:r="http://schemas.openxmlformats.org/officeDocument/2006/relationships" xmlns:p="http://schemas.openxmlformats.org/presentationml/2006/main">
   <p:cSld>
     <p:spTree>
       <p:nvGrpSpPr>
@@ -4455,7 +4521,14 @@
         <p:cNvGrpSpPr/>
         <p:nvPr/>
       </p:nvGrpSpPr>
-      <p:grpSpPr/>
+      <p:grpSpPr>
+        <a:xfrm>
+          <a:off x="0" y="0"/>
+          <a:ext cx="0" cy="0"/>
+          <a:chOff x="0" y="0"/>
+          <a:chExt cx="0" cy="0"/>
+        </a:xfrm>
+      </p:grpSpPr>
       <p:sp>
         <p:nvSpPr>
           <p:cNvPr id="2" name="Rectangle 1"/>
@@ -4496,6 +4569,7 @@
           <a:lstStyle/>
           <a:p>
             <a:pPr algn="ctr"/>
+            <a:endParaRPr/>
           </a:p>
         </p:txBody>
       </p:sp>
@@ -4539,6 +4613,7 @@
           <a:lstStyle/>
           <a:p>
             <a:pPr algn="ctr"/>
+            <a:endParaRPr/>
           </a:p>
         </p:txBody>
       </p:sp>
@@ -4650,6 +4725,7 @@
           <a:lstStyle/>
           <a:p>
             <a:pPr algn="ctr"/>
+            <a:endParaRPr/>
           </a:p>
         </p:txBody>
       </p:sp>
@@ -4662,7 +4738,7 @@
         <p:spPr>
           <a:xfrm>
             <a:off x="457200" y="1508760"/>
-            <a:ext cx="11247120" cy="731520"/>
+            <a:ext cx="11247120" cy="323165"/>
           </a:xfrm>
           <a:prstGeom prst="rect">
             <a:avLst/>
@@ -4677,12 +4753,60 @@
           <a:p>
             <a:pPr algn="l"/>
             <a:r>
-              <a:rPr sz="1500" b="0" i="0">
+              <a:rPr sz="1500" b="0" i="0" dirty="0">
                 <a:solidFill>
                   <a:srgbClr val="334155"/>
                 </a:solidFill>
               </a:rPr>
-              <a:t>De Unified AI Workspace Assistant verbindt Jira, Confluence, Dynamics 365 en Azure AD in één Teams-interface — aangedreven door Claude (Anthropic).</a:t>
+              <a:t>De Unified AI Workspace Assistant </a:t>
+            </a:r>
+            <a:r>
+              <a:rPr sz="1500" b="0" i="0" dirty="0" err="1">
+                <a:solidFill>
+                  <a:srgbClr val="334155"/>
+                </a:solidFill>
+              </a:rPr>
+              <a:t>verbindt</a:t>
+            </a:r>
+            <a:r>
+              <a:rPr sz="1500" b="0" i="0" dirty="0">
+                <a:solidFill>
+                  <a:srgbClr val="334155"/>
+                </a:solidFill>
+              </a:rPr>
+              <a:t> Jira, Confluence, Dynamics 365 in </a:t>
+            </a:r>
+            <a:r>
+              <a:rPr sz="1500" b="0" i="0" dirty="0" err="1">
+                <a:solidFill>
+                  <a:srgbClr val="334155"/>
+                </a:solidFill>
+              </a:rPr>
+              <a:t>één</a:t>
+            </a:r>
+            <a:r>
+              <a:rPr sz="1500" b="0" i="0" dirty="0">
+                <a:solidFill>
+                  <a:srgbClr val="334155"/>
+                </a:solidFill>
+              </a:rPr>
+              <a:t> Teams-interface — </a:t>
+            </a:r>
+            <a:r>
+              <a:rPr sz="1500" b="0" i="0" dirty="0" err="1">
+                <a:solidFill>
+                  <a:srgbClr val="334155"/>
+                </a:solidFill>
+              </a:rPr>
+              <a:t>aangedreven</a:t>
+            </a:r>
+            <a:r>
+              <a:rPr sz="1500" b="0" i="0" dirty="0">
+                <a:solidFill>
+                  <a:srgbClr val="334155"/>
+                </a:solidFill>
+              </a:rPr>
+              <a:t> door Claude (Anthropic).</a:t>
             </a:r>
           </a:p>
         </p:txBody>
@@ -4727,6 +4851,7 @@
           <a:lstStyle/>
           <a:p>
             <a:pPr algn="ctr"/>
+            <a:endParaRPr/>
           </a:p>
         </p:txBody>
       </p:sp>
@@ -4770,6 +4895,7 @@
           <a:lstStyle/>
           <a:p>
             <a:pPr algn="ctr"/>
+            <a:endParaRPr/>
           </a:p>
         </p:txBody>
       </p:sp>
@@ -4835,13 +4961,42 @@
               </a:spcBef>
             </a:pPr>
             <a:r>
-              <a:rPr sz="1300">
+              <a:rPr sz="1300" dirty="0">
                 <a:solidFill>
                   <a:srgbClr val="334155"/>
                 </a:solidFill>
               </a:rPr>
-              <a:t>→  Analyseert historiek</a:t>
-            </a:r>
+              <a:t>→  </a:t>
+            </a:r>
+            <a:r>
+              <a:rPr sz="1300" dirty="0" err="1">
+                <a:solidFill>
+                  <a:srgbClr val="334155"/>
+                </a:solidFill>
+              </a:rPr>
+              <a:t>Analyseert</a:t>
+            </a:r>
+            <a:r>
+              <a:rPr sz="1300" dirty="0">
+                <a:solidFill>
+                  <a:srgbClr val="334155"/>
+                </a:solidFill>
+              </a:rPr>
+              <a:t> </a:t>
+            </a:r>
+            <a:r>
+              <a:rPr sz="1300" dirty="0" err="1">
+                <a:solidFill>
+                  <a:srgbClr val="334155"/>
+                </a:solidFill>
+              </a:rPr>
+              <a:t>historiek</a:t>
+            </a:r>
+            <a:endParaRPr sz="1300" dirty="0">
+              <a:solidFill>
+                <a:srgbClr val="334155"/>
+              </a:solidFill>
+            </a:endParaRPr>
           </a:p>
           <a:p>
             <a:pPr>
@@ -4850,12 +5005,28 @@
               </a:spcBef>
             </a:pPr>
             <a:r>
-              <a:rPr sz="1300">
+              <a:rPr sz="1300" dirty="0">
                 <a:solidFill>
                   <a:srgbClr val="334155"/>
                 </a:solidFill>
               </a:rPr>
-              <a:t>→  Toewijzen met confidence %</a:t>
+              <a:t>→  </a:t>
+            </a:r>
+            <a:r>
+              <a:rPr sz="1300" dirty="0" err="1">
+                <a:solidFill>
+                  <a:srgbClr val="334155"/>
+                </a:solidFill>
+              </a:rPr>
+              <a:t>Toewijzen</a:t>
+            </a:r>
+            <a:r>
+              <a:rPr sz="1300" dirty="0">
+                <a:solidFill>
+                  <a:srgbClr val="334155"/>
+                </a:solidFill>
+              </a:rPr>
+              <a:t> met confidence %</a:t>
             </a:r>
           </a:p>
           <a:p>
@@ -4865,13 +5036,42 @@
               </a:spcBef>
             </a:pPr>
             <a:r>
-              <a:rPr sz="1300">
+              <a:rPr sz="1300" dirty="0">
                 <a:solidFill>
                   <a:srgbClr val="334155"/>
                 </a:solidFill>
               </a:rPr>
-              <a:t>→  Directe Teams-notificatie</a:t>
-            </a:r>
+              <a:t>→  </a:t>
+            </a:r>
+            <a:r>
+              <a:rPr sz="1300" dirty="0" err="1">
+                <a:solidFill>
+                  <a:srgbClr val="334155"/>
+                </a:solidFill>
+              </a:rPr>
+              <a:t>Directe</a:t>
+            </a:r>
+            <a:r>
+              <a:rPr sz="1300" dirty="0">
+                <a:solidFill>
+                  <a:srgbClr val="334155"/>
+                </a:solidFill>
+              </a:rPr>
+              <a:t> Teams-</a:t>
+            </a:r>
+            <a:r>
+              <a:rPr sz="1300" dirty="0" err="1">
+                <a:solidFill>
+                  <a:srgbClr val="334155"/>
+                </a:solidFill>
+              </a:rPr>
+              <a:t>notificatie</a:t>
+            </a:r>
+            <a:endParaRPr sz="1300" dirty="0">
+              <a:solidFill>
+                <a:srgbClr val="334155"/>
+              </a:solidFill>
+            </a:endParaRPr>
           </a:p>
         </p:txBody>
       </p:sp>
@@ -4915,6 +5115,7 @@
           <a:lstStyle/>
           <a:p>
             <a:pPr algn="ctr"/>
+            <a:endParaRPr/>
           </a:p>
         </p:txBody>
       </p:sp>
@@ -4958,6 +5159,7 @@
           <a:lstStyle/>
           <a:p>
             <a:pPr algn="ctr"/>
+            <a:endParaRPr/>
           </a:p>
         </p:txBody>
       </p:sp>
@@ -5103,6 +5305,7 @@
           <a:lstStyle/>
           <a:p>
             <a:pPr algn="ctr"/>
+            <a:endParaRPr/>
           </a:p>
         </p:txBody>
       </p:sp>
@@ -5146,6 +5349,7 @@
           <a:lstStyle/>
           <a:p>
             <a:pPr algn="ctr"/>
+            <a:endParaRPr/>
           </a:p>
         </p:txBody>
       </p:sp>
@@ -5291,6 +5495,7 @@
           <a:lstStyle/>
           <a:p>
             <a:pPr algn="ctr"/>
+            <a:endParaRPr/>
           </a:p>
         </p:txBody>
       </p:sp>
@@ -5334,6 +5539,7 @@
           <a:lstStyle/>
           <a:p>
             <a:pPr algn="ctr"/>
+            <a:endParaRPr/>
           </a:p>
         </p:txBody>
       </p:sp>
@@ -5399,13 +5605,42 @@
               </a:spcBef>
             </a:pPr>
             <a:r>
-              <a:rPr sz="1300">
+              <a:rPr sz="1300" dirty="0">
                 <a:solidFill>
                   <a:srgbClr val="334155"/>
                 </a:solidFill>
               </a:rPr>
-              <a:t>→  Oplossing → artikel</a:t>
-            </a:r>
+              <a:t>→  </a:t>
+            </a:r>
+            <a:r>
+              <a:rPr sz="1300" dirty="0" err="1">
+                <a:solidFill>
+                  <a:srgbClr val="334155"/>
+                </a:solidFill>
+              </a:rPr>
+              <a:t>Oplossing</a:t>
+            </a:r>
+            <a:r>
+              <a:rPr sz="1300" dirty="0">
+                <a:solidFill>
+                  <a:srgbClr val="334155"/>
+                </a:solidFill>
+              </a:rPr>
+              <a:t> → </a:t>
+            </a:r>
+            <a:r>
+              <a:rPr sz="1300" dirty="0" err="1">
+                <a:solidFill>
+                  <a:srgbClr val="334155"/>
+                </a:solidFill>
+              </a:rPr>
+              <a:t>artikel</a:t>
+            </a:r>
+            <a:endParaRPr sz="1300" dirty="0">
+              <a:solidFill>
+                <a:srgbClr val="334155"/>
+              </a:solidFill>
+            </a:endParaRPr>
           </a:p>
           <a:p>
             <a:pPr>
@@ -5414,7 +5649,7 @@
               </a:spcBef>
             </a:pPr>
             <a:r>
-              <a:rPr sz="1300">
+              <a:rPr sz="1300" dirty="0">
                 <a:solidFill>
                   <a:srgbClr val="334155"/>
                 </a:solidFill>
@@ -5429,13 +5664,26 @@
               </a:spcBef>
             </a:pPr>
             <a:r>
-              <a:rPr sz="1300">
+              <a:rPr sz="1300" dirty="0">
                 <a:solidFill>
                   <a:srgbClr val="334155"/>
                 </a:solidFill>
               </a:rPr>
-              <a:t>→  Kennis herbruikbaar</a:t>
-            </a:r>
+              <a:t>→  Kennis </a:t>
+            </a:r>
+            <a:r>
+              <a:rPr sz="1300" dirty="0" err="1">
+                <a:solidFill>
+                  <a:srgbClr val="334155"/>
+                </a:solidFill>
+              </a:rPr>
+              <a:t>herbruikbaar</a:t>
+            </a:r>
+            <a:endParaRPr sz="1300" dirty="0">
+              <a:solidFill>
+                <a:srgbClr val="334155"/>
+              </a:solidFill>
+            </a:endParaRPr>
           </a:p>
         </p:txBody>
       </p:sp>
@@ -5448,7 +5696,7 @@
 </file>
 
 <file path=ppt/slides/slide4.xml><?xml version="1.0" encoding="utf-8"?>
-<p:sld xmlns:a="http://schemas.openxmlformats.org/drawingml/2006/main" xmlns:p="http://schemas.openxmlformats.org/presentationml/2006/main" xmlns:r="http://schemas.openxmlformats.org/officeDocument/2006/relationships">
+<p:sld xmlns:a="http://schemas.openxmlformats.org/drawingml/2006/main" xmlns:r="http://schemas.openxmlformats.org/officeDocument/2006/relationships" xmlns:p="http://schemas.openxmlformats.org/presentationml/2006/main">
   <p:cSld>
     <p:spTree>
       <p:nvGrpSpPr>
@@ -5456,7 +5704,14 @@
         <p:cNvGrpSpPr/>
         <p:nvPr/>
       </p:nvGrpSpPr>
-      <p:grpSpPr/>
+      <p:grpSpPr>
+        <a:xfrm>
+          <a:off x="0" y="0"/>
+          <a:ext cx="0" cy="0"/>
+          <a:chOff x="0" y="0"/>
+          <a:chExt cx="0" cy="0"/>
+        </a:xfrm>
+      </p:grpSpPr>
       <p:sp>
         <p:nvSpPr>
           <p:cNvPr id="2" name="Rectangle 1"/>
@@ -5465,7 +5720,7 @@
         </p:nvSpPr>
         <p:spPr>
           <a:xfrm>
-            <a:off x="0" y="0"/>
+            <a:off x="-127" y="118872"/>
             <a:ext cx="12188952" cy="6858000"/>
           </a:xfrm>
           <a:prstGeom prst="rect">
@@ -5497,6 +5752,7 @@
           <a:lstStyle/>
           <a:p>
             <a:pPr algn="ctr"/>
+            <a:endParaRPr/>
           </a:p>
         </p:txBody>
       </p:sp>
@@ -5540,6 +5796,7 @@
           <a:lstStyle/>
           <a:p>
             <a:pPr algn="ctr"/>
+            <a:endParaRPr/>
           </a:p>
         </p:txBody>
       </p:sp>
@@ -5651,6 +5908,7 @@
           <a:lstStyle/>
           <a:p>
             <a:pPr algn="ctr"/>
+            <a:endParaRPr/>
           </a:p>
         </p:txBody>
       </p:sp>
@@ -5694,6 +5952,7 @@
           <a:lstStyle/>
           <a:p>
             <a:pPr algn="ctr"/>
+            <a:endParaRPr/>
           </a:p>
         </p:txBody>
       </p:sp>
@@ -5771,6 +6030,7 @@
           <a:lstStyle/>
           <a:p>
             <a:pPr algn="ctr"/>
+            <a:endParaRPr/>
           </a:p>
         </p:txBody>
       </p:sp>
@@ -5817,7 +6077,7 @@
         <p:spPr>
           <a:xfrm>
             <a:off x="1005840" y="1956816"/>
-            <a:ext cx="10515600" cy="310896"/>
+            <a:ext cx="10515600" cy="292388"/>
           </a:xfrm>
           <a:prstGeom prst="rect">
             <a:avLst/>
@@ -5832,13 +6092,42 @@
           <a:p>
             <a:pPr algn="l"/>
             <a:r>
-              <a:rPr sz="1300" b="0" i="0">
+              <a:rPr sz="1300" b="0" i="0" dirty="0">
                 <a:solidFill>
                   <a:srgbClr val="334155"/>
                 </a:solidFill>
               </a:rPr>
-              <a:t>Bot toont open tickets en vlagt onbeheerde tickets</a:t>
-            </a:r>
+              <a:t>Bot </a:t>
+            </a:r>
+            <a:r>
+              <a:rPr sz="1300" b="0" i="0" dirty="0" err="1">
+                <a:solidFill>
+                  <a:srgbClr val="334155"/>
+                </a:solidFill>
+              </a:rPr>
+              <a:t>toont</a:t>
+            </a:r>
+            <a:r>
+              <a:rPr sz="1300" b="0" i="0" dirty="0">
+                <a:solidFill>
+                  <a:srgbClr val="334155"/>
+                </a:solidFill>
+              </a:rPr>
+              <a:t> open tickets</a:t>
+            </a:r>
+            <a:r>
+              <a:rPr lang="nl-BE" sz="1300" b="0" i="0" dirty="0">
+                <a:solidFill>
+                  <a:srgbClr val="334155"/>
+                </a:solidFill>
+              </a:rPr>
+              <a:t> van mij en mijn collega’s</a:t>
+            </a:r>
+            <a:endParaRPr sz="1300" b="0" i="0" dirty="0">
+              <a:solidFill>
+                <a:srgbClr val="334155"/>
+              </a:solidFill>
+            </a:endParaRPr>
           </a:p>
         </p:txBody>
       </p:sp>
@@ -5882,6 +6171,7 @@
           <a:lstStyle/>
           <a:p>
             <a:pPr algn="ctr"/>
+            <a:endParaRPr/>
           </a:p>
         </p:txBody>
       </p:sp>
@@ -5959,74 +6249,7 @@
           <a:lstStyle/>
           <a:p>
             <a:pPr algn="ctr"/>
-          </a:p>
-        </p:txBody>
-      </p:sp>
-      <p:sp>
-        <p:nvSpPr>
-          <p:cNvPr id="15" name="TextBox 14"/>
-          <p:cNvSpPr txBox="1"/>
-          <p:nvPr/>
-        </p:nvSpPr>
-        <p:spPr>
-          <a:xfrm>
-            <a:off x="1005840" y="2551176"/>
-            <a:ext cx="3474720" cy="329184"/>
-          </a:xfrm>
-          <a:prstGeom prst="rect">
-            <a:avLst/>
-          </a:prstGeom>
-          <a:noFill/>
-        </p:spPr>
-        <p:txBody>
-          <a:bodyPr wrap="square">
-            <a:spAutoFit/>
-          </a:bodyPr>
-          <a:lstStyle/>
-          <a:p>
-            <a:pPr algn="l"/>
-            <a:r>
-              <a:rPr sz="1500" b="1" i="0">
-                <a:solidFill>
-                  <a:srgbClr val="0F1F35"/>
-                </a:solidFill>
-              </a:rPr>
-              <a:t>Ticket + Smart Assign</a:t>
-            </a:r>
-          </a:p>
-        </p:txBody>
-      </p:sp>
-      <p:sp>
-        <p:nvSpPr>
-          <p:cNvPr id="16" name="TextBox 15"/>
-          <p:cNvSpPr txBox="1"/>
-          <p:nvPr/>
-        </p:nvSpPr>
-        <p:spPr>
-          <a:xfrm>
-            <a:off x="1005840" y="2889504"/>
-            <a:ext cx="10515600" cy="310896"/>
-          </a:xfrm>
-          <a:prstGeom prst="rect">
-            <a:avLst/>
-          </a:prstGeom>
-          <a:noFill/>
-        </p:spPr>
-        <p:txBody>
-          <a:bodyPr wrap="square">
-            <a:spAutoFit/>
-          </a:bodyPr>
-          <a:lstStyle/>
-          <a:p>
-            <a:pPr algn="l"/>
-            <a:r>
-              <a:rPr sz="1300" b="0" i="0">
-                <a:solidFill>
-                  <a:srgbClr val="334155"/>
-                </a:solidFill>
-              </a:rPr>
-              <a:t>Nieuw ticket → historiek → juiste persoon met confidence %</a:t>
-            </a:r>
+            <a:endParaRPr/>
           </a:p>
         </p:txBody>
       </p:sp>
@@ -6070,6 +6293,7 @@
           <a:lstStyle/>
           <a:p>
             <a:pPr algn="ctr"/>
+            <a:endParaRPr/>
           </a:p>
         </p:txBody>
       </p:sp>
@@ -6147,74 +6371,7 @@
           <a:lstStyle/>
           <a:p>
             <a:pPr algn="ctr"/>
-          </a:p>
-        </p:txBody>
-      </p:sp>
-      <p:sp>
-        <p:nvSpPr>
-          <p:cNvPr id="20" name="TextBox 19"/>
-          <p:cNvSpPr txBox="1"/>
-          <p:nvPr/>
-        </p:nvSpPr>
-        <p:spPr>
-          <a:xfrm>
-            <a:off x="1005840" y="3483864"/>
-            <a:ext cx="3474720" cy="329184"/>
-          </a:xfrm>
-          <a:prstGeom prst="rect">
-            <a:avLst/>
-          </a:prstGeom>
-          <a:noFill/>
-        </p:spPr>
-        <p:txBody>
-          <a:bodyPr wrap="square">
-            <a:spAutoFit/>
-          </a:bodyPr>
-          <a:lstStyle/>
-          <a:p>
-            <a:pPr algn="l"/>
-            <a:r>
-              <a:rPr sz="1500" b="1" i="0">
-                <a:solidFill>
-                  <a:srgbClr val="0F1F35"/>
-                </a:solidFill>
-              </a:rPr>
-              <a:t>Oplossingszoeker</a:t>
-            </a:r>
-          </a:p>
-        </p:txBody>
-      </p:sp>
-      <p:sp>
-        <p:nvSpPr>
-          <p:cNvPr id="21" name="TextBox 20"/>
-          <p:cNvSpPr txBox="1"/>
-          <p:nvPr/>
-        </p:nvSpPr>
-        <p:spPr>
-          <a:xfrm>
-            <a:off x="1005840" y="3822192"/>
-            <a:ext cx="10515600" cy="310896"/>
-          </a:xfrm>
-          <a:prstGeom prst="rect">
-            <a:avLst/>
-          </a:prstGeom>
-          <a:noFill/>
-        </p:spPr>
-        <p:txBody>
-          <a:bodyPr wrap="square">
-            <a:spAutoFit/>
-          </a:bodyPr>
-          <a:lstStyle/>
-          <a:p>
-            <a:pPr algn="l"/>
-            <a:r>
-              <a:rPr sz="1300" b="0" i="0">
-                <a:solidFill>
-                  <a:srgbClr val="334155"/>
-                </a:solidFill>
-              </a:rPr>
-              <a:t>Claude vergelijkt met historiek → concrete aanpak + % succes</a:t>
-            </a:r>
+            <a:endParaRPr/>
           </a:p>
         </p:txBody>
       </p:sp>
@@ -6258,6 +6415,7 @@
           <a:lstStyle/>
           <a:p>
             <a:pPr algn="ctr"/>
+            <a:endParaRPr/>
           </a:p>
         </p:txBody>
       </p:sp>
@@ -6335,6 +6493,7 @@
           <a:lstStyle/>
           <a:p>
             <a:pPr algn="ctr"/>
+            <a:endParaRPr/>
           </a:p>
         </p:txBody>
       </p:sp>
@@ -6362,13 +6521,18 @@
           <a:p>
             <a:pPr algn="l"/>
             <a:r>
-              <a:rPr sz="1500" b="1" i="0">
+              <a:rPr lang="nl-BE" sz="1500" b="1" i="0" dirty="0">
                 <a:solidFill>
                   <a:srgbClr val="0F1F35"/>
                 </a:solidFill>
               </a:rPr>
-              <a:t>Auto-Resolve</a:t>
-            </a:r>
+              <a:t>Admin pagina’s</a:t>
+            </a:r>
+            <a:endParaRPr sz="1500" b="1" i="0" dirty="0">
+              <a:solidFill>
+                <a:srgbClr val="0F1F35"/>
+              </a:solidFill>
+            </a:endParaRPr>
           </a:p>
         </p:txBody>
       </p:sp>
@@ -6381,7 +6545,7 @@
         <p:spPr>
           <a:xfrm>
             <a:off x="1005840" y="4754880"/>
-            <a:ext cx="10515600" cy="310896"/>
+            <a:ext cx="10515600" cy="292388"/>
           </a:xfrm>
           <a:prstGeom prst="rect">
             <a:avLst/>
@@ -6396,13 +6560,18 @@
           <a:p>
             <a:pPr algn="l"/>
             <a:r>
-              <a:rPr sz="1300" b="0" i="0">
+              <a:rPr lang="nl-BE" sz="1300" b="0" i="0" dirty="0">
                 <a:solidFill>
                   <a:srgbClr val="334155"/>
                 </a:solidFill>
               </a:rPr>
-              <a:t>Analyseer, toewijzen, oplossing + statusupdate in één stap</a:t>
-            </a:r>
+              <a:t>Prompts beheren van de chatbot</a:t>
+            </a:r>
+            <a:endParaRPr sz="1300" b="0" i="0" dirty="0">
+              <a:solidFill>
+                <a:srgbClr val="334155"/>
+              </a:solidFill>
+            </a:endParaRPr>
           </a:p>
         </p:txBody>
       </p:sp>
@@ -6446,6 +6615,7 @@
           <a:lstStyle/>
           <a:p>
             <a:pPr algn="ctr"/>
+            <a:endParaRPr/>
           </a:p>
         </p:txBody>
       </p:sp>
@@ -6473,7 +6643,7 @@
           <a:p>
             <a:pPr algn="ctr"/>
             <a:r>
-              <a:rPr sz="2200" b="1" i="0">
+              <a:rPr sz="2200" b="1" i="0" dirty="0">
                 <a:solidFill>
                   <a:srgbClr val="FFFFFF"/>
                 </a:solidFill>
@@ -6523,6 +6693,7 @@
           <a:lstStyle/>
           <a:p>
             <a:pPr algn="ctr"/>
+            <a:endParaRPr/>
           </a:p>
         </p:txBody>
       </p:sp>
@@ -6550,13 +6721,18 @@
           <a:p>
             <a:pPr algn="l"/>
             <a:r>
-              <a:rPr sz="1500" b="1" i="0">
+              <a:rPr lang="nl-BE" sz="1500" b="1" dirty="0">
                 <a:solidFill>
                   <a:srgbClr val="0F1F35"/>
                 </a:solidFill>
               </a:rPr>
-              <a:t>Kenniscapture</a:t>
-            </a:r>
+              <a:t>Kennisbank beheer</a:t>
+            </a:r>
+            <a:endParaRPr sz="1500" b="1" i="0" dirty="0">
+              <a:solidFill>
+                <a:srgbClr val="0F1F35"/>
+              </a:solidFill>
+            </a:endParaRPr>
           </a:p>
         </p:txBody>
       </p:sp>
@@ -6569,7 +6745,7 @@
         <p:spPr>
           <a:xfrm>
             <a:off x="1005840" y="5687568"/>
-            <a:ext cx="10515600" cy="310896"/>
+            <a:ext cx="10515600" cy="292388"/>
           </a:xfrm>
           <a:prstGeom prst="rect">
             <a:avLst/>
@@ -6584,13 +6760,254 @@
           <a:p>
             <a:pPr algn="l"/>
             <a:r>
-              <a:rPr sz="1300" b="0" i="0">
+              <a:rPr lang="nl-BE" sz="1300" b="0" i="0" dirty="0">
                 <a:solidFill>
                   <a:srgbClr val="334155"/>
                 </a:solidFill>
               </a:rPr>
-              <a:t>Oplossing → kennisartikel auto-gepubliceerd in Confluence</a:t>
-            </a:r>
+              <a:t>Kenninsbank beheer opzoeken en bij maken</a:t>
+            </a:r>
+            <a:endParaRPr sz="1300" b="0" i="0" dirty="0">
+              <a:solidFill>
+                <a:srgbClr val="334155"/>
+              </a:solidFill>
+            </a:endParaRPr>
+          </a:p>
+        </p:txBody>
+      </p:sp>
+      <p:sp>
+        <p:nvSpPr>
+          <p:cNvPr id="32" name="TextBox 31">
+            <a:extLst>
+              <a:ext uri="{FF2B5EF4-FFF2-40B4-BE49-F238E27FC236}">
+                <a16:creationId xmlns:a16="http://schemas.microsoft.com/office/drawing/2014/main" id="{C3C67E54-FA51-5459-50E5-53CD8F9CCC7F}"/>
+              </a:ext>
+            </a:extLst>
+          </p:cNvPr>
+          <p:cNvSpPr txBox="1"/>
+          <p:nvPr/>
+        </p:nvSpPr>
+        <p:spPr>
+          <a:xfrm>
+            <a:off x="1005840" y="2557960"/>
+            <a:ext cx="3474720" cy="329184"/>
+          </a:xfrm>
+          <a:prstGeom prst="rect">
+            <a:avLst/>
+          </a:prstGeom>
+          <a:noFill/>
+        </p:spPr>
+        <p:txBody>
+          <a:bodyPr wrap="square">
+            <a:spAutoFit/>
+          </a:bodyPr>
+          <a:lstStyle/>
+          <a:p>
+            <a:pPr algn="l"/>
+            <a:r>
+              <a:rPr lang="nl-BE" sz="1500" b="1" dirty="0">
+                <a:solidFill>
+                  <a:srgbClr val="0F1F35"/>
+                </a:solidFill>
+              </a:rPr>
+              <a:t>Oplossingen zoeken</a:t>
+            </a:r>
+            <a:endParaRPr sz="1500" b="1" i="0" dirty="0">
+              <a:solidFill>
+                <a:srgbClr val="0F1F35"/>
+              </a:solidFill>
+            </a:endParaRPr>
+          </a:p>
+        </p:txBody>
+      </p:sp>
+      <p:sp>
+        <p:nvSpPr>
+          <p:cNvPr id="33" name="TextBox 32">
+            <a:extLst>
+              <a:ext uri="{FF2B5EF4-FFF2-40B4-BE49-F238E27FC236}">
+                <a16:creationId xmlns:a16="http://schemas.microsoft.com/office/drawing/2014/main" id="{4CBFAC1E-BC8D-CB7F-D661-686A64B157F0}"/>
+              </a:ext>
+            </a:extLst>
+          </p:cNvPr>
+          <p:cNvSpPr txBox="1"/>
+          <p:nvPr/>
+        </p:nvSpPr>
+        <p:spPr>
+          <a:xfrm>
+            <a:off x="1055493" y="2872715"/>
+            <a:ext cx="10515600" cy="292388"/>
+          </a:xfrm>
+          <a:prstGeom prst="rect">
+            <a:avLst/>
+          </a:prstGeom>
+          <a:noFill/>
+        </p:spPr>
+        <p:txBody>
+          <a:bodyPr wrap="square">
+            <a:spAutoFit/>
+          </a:bodyPr>
+          <a:lstStyle/>
+          <a:p>
+            <a:pPr algn="l"/>
+            <a:r>
+              <a:rPr sz="1300" b="0" i="0" dirty="0">
+                <a:solidFill>
+                  <a:srgbClr val="334155"/>
+                </a:solidFill>
+              </a:rPr>
+              <a:t>Claude </a:t>
+            </a:r>
+            <a:r>
+              <a:rPr sz="1300" b="0" i="0" dirty="0" err="1">
+                <a:solidFill>
+                  <a:srgbClr val="334155"/>
+                </a:solidFill>
+              </a:rPr>
+              <a:t>vergelijkt</a:t>
+            </a:r>
+            <a:r>
+              <a:rPr sz="1300" b="0" i="0" dirty="0">
+                <a:solidFill>
+                  <a:srgbClr val="334155"/>
+                </a:solidFill>
+              </a:rPr>
+              <a:t> met </a:t>
+            </a:r>
+            <a:r>
+              <a:rPr sz="1300" b="0" i="0" dirty="0" err="1">
+                <a:solidFill>
+                  <a:srgbClr val="334155"/>
+                </a:solidFill>
+              </a:rPr>
+              <a:t>historiek</a:t>
+            </a:r>
+            <a:r>
+              <a:rPr sz="1300" b="0" i="0" dirty="0">
+                <a:solidFill>
+                  <a:srgbClr val="334155"/>
+                </a:solidFill>
+              </a:rPr>
+              <a:t> → </a:t>
+            </a:r>
+            <a:r>
+              <a:rPr lang="nl-BE" sz="1300" b="0" i="0" dirty="0">
+                <a:solidFill>
+                  <a:srgbClr val="334155"/>
+                </a:solidFill>
+              </a:rPr>
+              <a:t>toont beschikbare oplossingen</a:t>
+            </a:r>
+            <a:endParaRPr sz="1300" b="0" i="0" dirty="0">
+              <a:solidFill>
+                <a:srgbClr val="334155"/>
+              </a:solidFill>
+            </a:endParaRPr>
+          </a:p>
+        </p:txBody>
+      </p:sp>
+      <p:sp>
+        <p:nvSpPr>
+          <p:cNvPr id="36" name="TextBox 35">
+            <a:extLst>
+              <a:ext uri="{FF2B5EF4-FFF2-40B4-BE49-F238E27FC236}">
+                <a16:creationId xmlns:a16="http://schemas.microsoft.com/office/drawing/2014/main" id="{83507CBD-D684-A64F-DE67-49DE41A66E71}"/>
+              </a:ext>
+            </a:extLst>
+          </p:cNvPr>
+          <p:cNvSpPr txBox="1"/>
+          <p:nvPr/>
+        </p:nvSpPr>
+        <p:spPr>
+          <a:xfrm>
+            <a:off x="1005840" y="3442003"/>
+            <a:ext cx="3474720" cy="329184"/>
+          </a:xfrm>
+          <a:prstGeom prst="rect">
+            <a:avLst/>
+          </a:prstGeom>
+          <a:noFill/>
+        </p:spPr>
+        <p:txBody>
+          <a:bodyPr wrap="square">
+            <a:spAutoFit/>
+          </a:bodyPr>
+          <a:lstStyle/>
+          <a:p>
+            <a:pPr algn="l"/>
+            <a:r>
+              <a:rPr sz="1500" b="1" i="0" dirty="0">
+                <a:solidFill>
+                  <a:srgbClr val="0F1F35"/>
+                </a:solidFill>
+              </a:rPr>
+              <a:t>Ticke</a:t>
+            </a:r>
+            <a:r>
+              <a:rPr lang="nl-BE" sz="1500" b="1" i="0" dirty="0">
+                <a:solidFill>
+                  <a:srgbClr val="0F1F35"/>
+                </a:solidFill>
+              </a:rPr>
+              <a:t>t</a:t>
+            </a:r>
+            <a:endParaRPr sz="1500" b="1" i="0" dirty="0">
+              <a:solidFill>
+                <a:srgbClr val="0F1F35"/>
+              </a:solidFill>
+            </a:endParaRPr>
+          </a:p>
+        </p:txBody>
+      </p:sp>
+      <p:sp>
+        <p:nvSpPr>
+          <p:cNvPr id="37" name="TextBox 36">
+            <a:extLst>
+              <a:ext uri="{FF2B5EF4-FFF2-40B4-BE49-F238E27FC236}">
+                <a16:creationId xmlns:a16="http://schemas.microsoft.com/office/drawing/2014/main" id="{80D7A154-C0E7-2458-0042-1E9E768FC32D}"/>
+              </a:ext>
+            </a:extLst>
+          </p:cNvPr>
+          <p:cNvSpPr txBox="1"/>
+          <p:nvPr/>
+        </p:nvSpPr>
+        <p:spPr>
+          <a:xfrm>
+            <a:off x="1005840" y="3752899"/>
+            <a:ext cx="10515600" cy="292388"/>
+          </a:xfrm>
+          <a:prstGeom prst="rect">
+            <a:avLst/>
+          </a:prstGeom>
+          <a:noFill/>
+        </p:spPr>
+        <p:txBody>
+          <a:bodyPr wrap="square">
+            <a:spAutoFit/>
+          </a:bodyPr>
+          <a:lstStyle/>
+          <a:p>
+            <a:pPr algn="l"/>
+            <a:r>
+              <a:rPr sz="1300" b="0" i="0" dirty="0">
+                <a:solidFill>
+                  <a:srgbClr val="334155"/>
+                </a:solidFill>
+              </a:rPr>
+              <a:t>Nieuw ticket</a:t>
+            </a:r>
+            <a:r>
+              <a:rPr lang="nl-BE" sz="1300" b="0" i="0" dirty="0">
+                <a:solidFill>
+                  <a:srgbClr val="334155"/>
+                </a:solidFill>
+              </a:rPr>
+              <a:t> aanmaken via bestaande flow</a:t>
+            </a:r>
+            <a:endParaRPr sz="1300" b="0" i="0" dirty="0">
+              <a:solidFill>
+                <a:srgbClr val="334155"/>
+              </a:solidFill>
+            </a:endParaRPr>
           </a:p>
         </p:txBody>
       </p:sp>
@@ -6603,7 +7020,7 @@
 </file>
 
 <file path=ppt/slides/slide5.xml><?xml version="1.0" encoding="utf-8"?>
-<p:sld xmlns:a="http://schemas.openxmlformats.org/drawingml/2006/main" xmlns:p="http://schemas.openxmlformats.org/presentationml/2006/main" xmlns:r="http://schemas.openxmlformats.org/officeDocument/2006/relationships">
+<p:sld xmlns:a="http://schemas.openxmlformats.org/drawingml/2006/main" xmlns:r="http://schemas.openxmlformats.org/officeDocument/2006/relationships" xmlns:p="http://schemas.openxmlformats.org/presentationml/2006/main">
   <p:cSld>
     <p:spTree>
       <p:nvGrpSpPr>
@@ -6611,7 +7028,14 @@
         <p:cNvGrpSpPr/>
         <p:nvPr/>
       </p:nvGrpSpPr>
-      <p:grpSpPr/>
+      <p:grpSpPr>
+        <a:xfrm>
+          <a:off x="0" y="0"/>
+          <a:ext cx="0" cy="0"/>
+          <a:chOff x="0" y="0"/>
+          <a:chExt cx="0" cy="0"/>
+        </a:xfrm>
+      </p:grpSpPr>
       <p:sp>
         <p:nvSpPr>
           <p:cNvPr id="2" name="Rectangle 1"/>
@@ -6652,6 +7076,7 @@
           <a:lstStyle/>
           <a:p>
             <a:pPr algn="ctr"/>
+            <a:endParaRPr/>
           </a:p>
         </p:txBody>
       </p:sp>
@@ -6695,6 +7120,7 @@
           <a:lstStyle/>
           <a:p>
             <a:pPr algn="ctr"/>
+            <a:endParaRPr/>
           </a:p>
         </p:txBody>
       </p:sp>
@@ -6806,6 +7232,7 @@
           <a:lstStyle/>
           <a:p>
             <a:pPr algn="ctr"/>
+            <a:endParaRPr/>
           </a:p>
         </p:txBody>
       </p:sp>
@@ -6849,6 +7276,7 @@
           <a:lstStyle/>
           <a:p>
             <a:pPr algn="ctr"/>
+            <a:endParaRPr/>
           </a:p>
         </p:txBody>
       </p:sp>
@@ -6892,6 +7320,7 @@
           <a:lstStyle/>
           <a:p>
             <a:pPr algn="ctr"/>
+            <a:endParaRPr/>
           </a:p>
         </p:txBody>
       </p:sp>
@@ -7086,6 +7515,7 @@
           <a:lstStyle/>
           <a:p>
             <a:pPr algn="ctr"/>
+            <a:endParaRPr/>
           </a:p>
         </p:txBody>
       </p:sp>
@@ -7129,6 +7559,7 @@
           <a:lstStyle/>
           <a:p>
             <a:pPr algn="ctr"/>
+            <a:endParaRPr/>
           </a:p>
         </p:txBody>
       </p:sp>
@@ -7273,7 +7704,7 @@
 </file>
 
 <file path=ppt/slides/slide6.xml><?xml version="1.0" encoding="utf-8"?>
-<p:sld xmlns:a="http://schemas.openxmlformats.org/drawingml/2006/main" xmlns:p="http://schemas.openxmlformats.org/presentationml/2006/main" xmlns:r="http://schemas.openxmlformats.org/officeDocument/2006/relationships">
+<p:sld xmlns:a="http://schemas.openxmlformats.org/drawingml/2006/main" xmlns:r="http://schemas.openxmlformats.org/officeDocument/2006/relationships" xmlns:p="http://schemas.openxmlformats.org/presentationml/2006/main">
   <p:cSld>
     <p:spTree>
       <p:nvGrpSpPr>
@@ -7281,7 +7712,14 @@
         <p:cNvGrpSpPr/>
         <p:nvPr/>
       </p:nvGrpSpPr>
-      <p:grpSpPr/>
+      <p:grpSpPr>
+        <a:xfrm>
+          <a:off x="0" y="0"/>
+          <a:ext cx="0" cy="0"/>
+          <a:chOff x="0" y="0"/>
+          <a:chExt cx="0" cy="0"/>
+        </a:xfrm>
+      </p:grpSpPr>
       <p:sp>
         <p:nvSpPr>
           <p:cNvPr id="2" name="Rectangle 1"/>
@@ -7322,6 +7760,7 @@
           <a:lstStyle/>
           <a:p>
             <a:pPr algn="ctr"/>
+            <a:endParaRPr/>
           </a:p>
         </p:txBody>
       </p:sp>
@@ -7365,6 +7804,7 @@
           <a:lstStyle/>
           <a:p>
             <a:pPr algn="ctr"/>
+            <a:endParaRPr/>
           </a:p>
         </p:txBody>
       </p:sp>
@@ -7476,6 +7916,7 @@
           <a:lstStyle/>
           <a:p>
             <a:pPr algn="ctr"/>
+            <a:endParaRPr/>
           </a:p>
         </p:txBody>
       </p:sp>
@@ -7519,6 +7960,7 @@
           <a:lstStyle/>
           <a:p>
             <a:pPr algn="ctr"/>
+            <a:endParaRPr/>
           </a:p>
         </p:txBody>
       </p:sp>
@@ -7562,6 +8004,7 @@
           <a:lstStyle/>
           <a:p>
             <a:pPr algn="ctr"/>
+            <a:endParaRPr/>
           </a:p>
         </p:txBody>
       </p:sp>
@@ -7674,6 +8117,7 @@
           <a:lstStyle/>
           <a:p>
             <a:pPr algn="ctr"/>
+            <a:endParaRPr/>
           </a:p>
         </p:txBody>
       </p:sp>
@@ -7717,6 +8161,7 @@
           <a:lstStyle/>
           <a:p>
             <a:pPr algn="ctr"/>
+            <a:endParaRPr/>
           </a:p>
         </p:txBody>
       </p:sp>
@@ -7828,6 +8273,7 @@
           <a:lstStyle/>
           <a:p>
             <a:pPr algn="ctr"/>
+            <a:endParaRPr/>
           </a:p>
         </p:txBody>
       </p:sp>
@@ -7871,6 +8317,7 @@
           <a:lstStyle/>
           <a:p>
             <a:pPr algn="ctr"/>
+            <a:endParaRPr/>
           </a:p>
         </p:txBody>
       </p:sp>
@@ -7982,6 +8429,7 @@
           <a:lstStyle/>
           <a:p>
             <a:pPr algn="ctr"/>
+            <a:endParaRPr/>
           </a:p>
         </p:txBody>
       </p:sp>
@@ -8025,6 +8473,7 @@
           <a:lstStyle/>
           <a:p>
             <a:pPr algn="ctr"/>
+            <a:endParaRPr/>
           </a:p>
         </p:txBody>
       </p:sp>
@@ -8136,6 +8585,7 @@
           <a:lstStyle/>
           <a:p>
             <a:pPr algn="ctr"/>
+            <a:endParaRPr/>
           </a:p>
         </p:txBody>
       </p:sp>
@@ -8179,6 +8629,7 @@
           <a:lstStyle/>
           <a:p>
             <a:pPr algn="ctr"/>
+            <a:endParaRPr/>
           </a:p>
         </p:txBody>
       </p:sp>
@@ -8290,6 +8741,7 @@
           <a:lstStyle/>
           <a:p>
             <a:pPr algn="ctr"/>
+            <a:endParaRPr/>
           </a:p>
         </p:txBody>
       </p:sp>
@@ -8333,6 +8785,7 @@
           <a:lstStyle/>
           <a:p>
             <a:pPr algn="ctr"/>
+            <a:endParaRPr/>
           </a:p>
         </p:txBody>
       </p:sp>
@@ -8413,7 +8866,7 @@
 </file>
 
 <file path=ppt/slides/slide7.xml><?xml version="1.0" encoding="utf-8"?>
-<p:sld xmlns:a="http://schemas.openxmlformats.org/drawingml/2006/main" xmlns:p="http://schemas.openxmlformats.org/presentationml/2006/main" xmlns:r="http://schemas.openxmlformats.org/officeDocument/2006/relationships">
+<p:sld xmlns:a="http://schemas.openxmlformats.org/drawingml/2006/main" xmlns:r="http://schemas.openxmlformats.org/officeDocument/2006/relationships" xmlns:p="http://schemas.openxmlformats.org/presentationml/2006/main">
   <p:cSld>
     <p:spTree>
       <p:nvGrpSpPr>
@@ -8421,7 +8874,14 @@
         <p:cNvGrpSpPr/>
         <p:nvPr/>
       </p:nvGrpSpPr>
-      <p:grpSpPr/>
+      <p:grpSpPr>
+        <a:xfrm>
+          <a:off x="0" y="0"/>
+          <a:ext cx="0" cy="0"/>
+          <a:chOff x="0" y="0"/>
+          <a:chExt cx="0" cy="0"/>
+        </a:xfrm>
+      </p:grpSpPr>
       <p:sp>
         <p:nvSpPr>
           <p:cNvPr id="2" name="Rectangle 1"/>
@@ -8462,6 +8922,7 @@
           <a:lstStyle/>
           <a:p>
             <a:pPr algn="ctr"/>
+            <a:endParaRPr/>
           </a:p>
         </p:txBody>
       </p:sp>
@@ -8505,6 +8966,7 @@
           <a:lstStyle/>
           <a:p>
             <a:pPr algn="ctr"/>
+            <a:endParaRPr/>
           </a:p>
         </p:txBody>
       </p:sp>
@@ -8616,6 +9078,7 @@
           <a:lstStyle/>
           <a:p>
             <a:pPr algn="ctr"/>
+            <a:endParaRPr/>
           </a:p>
         </p:txBody>
       </p:sp>
@@ -8659,6 +9122,7 @@
           <a:lstStyle/>
           <a:p>
             <a:pPr algn="ctr"/>
+            <a:endParaRPr/>
           </a:p>
         </p:txBody>
       </p:sp>
@@ -8702,6 +9166,7 @@
           <a:lstStyle/>
           <a:p>
             <a:pPr algn="ctr"/>
+            <a:endParaRPr/>
           </a:p>
         </p:txBody>
       </p:sp>
@@ -8813,6 +9278,7 @@
           <a:lstStyle/>
           <a:p>
             <a:pPr algn="ctr"/>
+            <a:endParaRPr/>
           </a:p>
         </p:txBody>
       </p:sp>
@@ -8856,6 +9322,7 @@
           <a:lstStyle/>
           <a:p>
             <a:pPr algn="ctr"/>
+            <a:endParaRPr/>
           </a:p>
         </p:txBody>
       </p:sp>
@@ -8967,6 +9434,7 @@
           <a:lstStyle/>
           <a:p>
             <a:pPr algn="ctr"/>
+            <a:endParaRPr/>
           </a:p>
         </p:txBody>
       </p:sp>
@@ -9010,6 +9478,7 @@
           <a:lstStyle/>
           <a:p>
             <a:pPr algn="ctr"/>
+            <a:endParaRPr/>
           </a:p>
         </p:txBody>
       </p:sp>
@@ -9121,6 +9590,7 @@
           <a:lstStyle/>
           <a:p>
             <a:pPr algn="ctr"/>
+            <a:endParaRPr/>
           </a:p>
         </p:txBody>
       </p:sp>
@@ -9164,6 +9634,7 @@
           <a:lstStyle/>
           <a:p>
             <a:pPr algn="ctr"/>
+            <a:endParaRPr/>
           </a:p>
         </p:txBody>
       </p:sp>
@@ -9275,6 +9746,7 @@
           <a:lstStyle/>
           <a:p>
             <a:pPr algn="ctr"/>
+            <a:endParaRPr/>
           </a:p>
         </p:txBody>
       </p:sp>
@@ -9318,6 +9790,7 @@
           <a:lstStyle/>
           <a:p>
             <a:pPr algn="ctr"/>
+            <a:endParaRPr/>
           </a:p>
         </p:txBody>
       </p:sp>
@@ -9429,6 +9902,7 @@
           <a:lstStyle/>
           <a:p>
             <a:pPr algn="ctr"/>
+            <a:endParaRPr/>
           </a:p>
         </p:txBody>
       </p:sp>
@@ -9472,6 +9946,7 @@
           <a:lstStyle/>
           <a:p>
             <a:pPr algn="ctr"/>
+            <a:endParaRPr/>
           </a:p>
         </p:txBody>
       </p:sp>
@@ -9552,7 +10027,7 @@
 </file>
 
 <file path=ppt/slides/slide8.xml><?xml version="1.0" encoding="utf-8"?>
-<p:sld xmlns:a="http://schemas.openxmlformats.org/drawingml/2006/main" xmlns:p="http://schemas.openxmlformats.org/presentationml/2006/main" xmlns:r="http://schemas.openxmlformats.org/officeDocument/2006/relationships">
+<p:sld xmlns:a="http://schemas.openxmlformats.org/drawingml/2006/main" xmlns:r="http://schemas.openxmlformats.org/officeDocument/2006/relationships" xmlns:p="http://schemas.openxmlformats.org/presentationml/2006/main">
   <p:cSld>
     <p:spTree>
       <p:nvGrpSpPr>
@@ -9560,7 +10035,14 @@
         <p:cNvGrpSpPr/>
         <p:nvPr/>
       </p:nvGrpSpPr>
-      <p:grpSpPr/>
+      <p:grpSpPr>
+        <a:xfrm>
+          <a:off x="0" y="0"/>
+          <a:ext cx="0" cy="0"/>
+          <a:chOff x="0" y="0"/>
+          <a:chExt cx="0" cy="0"/>
+        </a:xfrm>
+      </p:grpSpPr>
       <p:sp>
         <p:nvSpPr>
           <p:cNvPr id="2" name="Rectangle 1"/>
@@ -9601,6 +10083,7 @@
           <a:lstStyle/>
           <a:p>
             <a:pPr algn="ctr"/>
+            <a:endParaRPr/>
           </a:p>
         </p:txBody>
       </p:sp>
@@ -9644,6 +10127,7 @@
           <a:lstStyle/>
           <a:p>
             <a:pPr algn="ctr"/>
+            <a:endParaRPr/>
           </a:p>
         </p:txBody>
       </p:sp>

</xml_diff>